<commit_message>
Slides: shorten sd-09-011 copy, re-export PPTX
Co-Authored-By: Claude Opus 5.5 <noreply@anthropic.com>
Claude-Session: https://claude.ai/code/session_014EdyZwPF7XnU2uvEPKZ7Pf
</commit_message>
<xml_diff>
--- a/system-design-101/vi/lessons/sd-09-011/slides/sd-09-011.pptx
+++ b/system-design-101/vi/lessons/sd-09-011/slides/sd-09-011.pptx
@@ -4810,10 +4810,10 @@
                 <a:ea typeface="Be Vietnam Pro" pitchFamily="34" charset="-122"/>
                 <a:cs typeface="Be Vietnam Pro" pitchFamily="34" charset="-120"/>
               </a:rPr>
-              <a:t> kỹ</a:t>
-            </a:r>
-            <a:r>
-              <a:rPr lang="en-US" sz="2250" b="1" dirty="0" spc="-2" kern="0">
+              <a:t> nào</a:t>
+            </a:r>
+            <a:r>
+              <a:rPr lang="en-US" sz="2250" b="1" dirty="0" spc="5" kern="0">
                 <a:solidFill>
                   <a:srgbClr val="E8472B"/>
                 </a:solidFill>
@@ -4821,10 +4821,10 @@
                 <a:ea typeface="Be Vietnam Pro" pitchFamily="34" charset="-122"/>
                 <a:cs typeface="Be Vietnam Pro" pitchFamily="34" charset="-120"/>
               </a:rPr>
-              <a:t> thuật</a:t>
-            </a:r>
-            <a:r>
-              <a:rPr lang="en-US" sz="2250" b="1" dirty="0" spc="3" kern="0">
+              <a:t> bảo</a:t>
+            </a:r>
+            <a:r>
+              <a:rPr lang="en-US" sz="2250" b="1" dirty="0" spc="9" kern="0">
                 <a:solidFill>
                   <a:srgbClr val="E8472B"/>
                 </a:solidFill>
@@ -4832,51 +4832,7 @@
                 <a:ea typeface="Be Vietnam Pro" pitchFamily="34" charset="-122"/>
                 <a:cs typeface="Be Vietnam Pro" pitchFamily="34" charset="-120"/>
               </a:rPr>
-              <a:t> nào</a:t>
-            </a:r>
-            <a:r>
-              <a:rPr lang="en-US" sz="2250" b="1" dirty="0" spc="5" kern="0">
-                <a:solidFill>
-                  <a:srgbClr val="E8472B"/>
-                </a:solidFill>
-                <a:latin typeface="Be Vietnam Pro" pitchFamily="34" charset="0"/>
-                <a:ea typeface="Be Vietnam Pro" pitchFamily="34" charset="-122"/>
-                <a:cs typeface="Be Vietnam Pro" pitchFamily="34" charset="-120"/>
-              </a:rPr>
-              <a:t> bảo</a:t>
-            </a:r>
-            <a:r>
-              <a:rPr lang="en-US" sz="2250" b="1" dirty="0" spc="10" kern="0">
-                <a:solidFill>
-                  <a:srgbClr val="E8472B"/>
-                </a:solidFill>
-                <a:latin typeface="Be Vietnam Pro" pitchFamily="34" charset="0"/>
-                <a:ea typeface="Be Vietnam Pro" pitchFamily="34" charset="-122"/>
-                <a:cs typeface="Be Vietnam Pro" pitchFamily="34" charset="-120"/>
-              </a:rPr>
               <a:t> đảm</a:t>
-            </a:r>
-            <a:r>
-              <a:rPr lang="en-US" sz="2250" b="1" dirty="0" spc="3" kern="0">
-                <a:solidFill>
-                  <a:srgbClr val="E8472B"/>
-                </a:solidFill>
-                <a:latin typeface="Be Vietnam Pro" pitchFamily="34" charset="0"/>
-                <a:ea typeface="Be Vietnam Pro" pitchFamily="34" charset="-122"/>
-                <a:cs typeface="Be Vietnam Pro" pitchFamily="34" charset="-120"/>
-              </a:rPr>
-              <a:t> vị</a:t>
-            </a:r>
-            <a:r>
-              <a:rPr lang="en-US" sz="2250" b="1" dirty="0" spc="10" kern="0">
-                <a:solidFill>
-                  <a:srgbClr val="E8472B"/>
-                </a:solidFill>
-                <a:latin typeface="Be Vietnam Pro" pitchFamily="34" charset="0"/>
-                <a:ea typeface="Be Vietnam Pro" pitchFamily="34" charset="-122"/>
-                <a:cs typeface="Be Vietnam Pro" pitchFamily="34" charset="-120"/>
-              </a:rPr>
-              <a:t> trí</a:t>
             </a:r>
             <a:r>
               <a:rPr lang="en-US" sz="2250" b="1" dirty="0" spc="21" kern="0">
@@ -6512,6 +6468,28 @@
               <a:t>Trang</a:t>
             </a:r>
             <a:r>
+              <a:rPr lang="en-US" sz="2400" dirty="0" spc="-6" kern="0">
+                <a:solidFill>
+                  <a:srgbClr val="E4E1D8"/>
+                </a:solidFill>
+                <a:latin typeface="Be Vietnam Pro" pitchFamily="34" charset="0"/>
+                <a:ea typeface="Be Vietnam Pro" pitchFamily="34" charset="-122"/>
+                <a:cs typeface="Be Vietnam Pro" pitchFamily="34" charset="-120"/>
+              </a:rPr>
+              <a:t> JavaScript</a:t>
+            </a:r>
+            <a:r>
+              <a:rPr lang="en-US" sz="2400" dirty="0" spc="1" kern="0">
+                <a:solidFill>
+                  <a:srgbClr val="E4E1D8"/>
+                </a:solidFill>
+                <a:latin typeface="Be Vietnam Pro" pitchFamily="34" charset="0"/>
+                <a:ea typeface="Be Vietnam Pro" pitchFamily="34" charset="-122"/>
+                <a:cs typeface="Be Vietnam Pro" pitchFamily="34" charset="-120"/>
+              </a:rPr>
+              <a:t> không</a:t>
+            </a:r>
+            <a:r>
               <a:rPr lang="en-US" sz="2400" dirty="0" spc="3" kern="0">
                 <a:solidFill>
                   <a:srgbClr val="E4E1D8"/>
@@ -6520,10 +6498,10 @@
                 <a:ea typeface="Be Vietnam Pro" pitchFamily="34" charset="-122"/>
                 <a:cs typeface="Be Vietnam Pro" pitchFamily="34" charset="-120"/>
               </a:rPr>
-              <a:t> dùng</a:t>
-            </a:r>
-            <a:r>
-              <a:rPr lang="en-US" sz="2400" dirty="0" spc="-6" kern="0">
+              <a:t> tự</a:t>
+            </a:r>
+            <a:r>
+              <a:rPr lang="en-US" sz="2400" dirty="0" spc="1" kern="0">
                 <a:solidFill>
                   <a:srgbClr val="E4E1D8"/>
                 </a:solidFill>
@@ -6531,10 +6509,10 @@
                 <a:ea typeface="Be Vietnam Pro" pitchFamily="34" charset="-122"/>
                 <a:cs typeface="Be Vietnam Pro" pitchFamily="34" charset="-120"/>
               </a:rPr>
-              <a:t> JavaScript</a:t>
-            </a:r>
-            <a:r>
-              <a:rPr lang="en-US" sz="2400" dirty="0" spc="1" kern="0">
+              <a:t> bị</a:t>
+            </a:r>
+            <a:r>
+              <a:rPr lang="en-US" sz="2400" dirty="0" spc="-1" kern="0">
                 <a:solidFill>
                   <a:srgbClr val="E4E1D8"/>
                 </a:solidFill>
@@ -6542,10 +6520,10 @@
                 <a:ea typeface="Be Vietnam Pro" pitchFamily="34" charset="-122"/>
                 <a:cs typeface="Be Vietnam Pro" pitchFamily="34" charset="-120"/>
               </a:rPr>
-              <a:t> không</a:t>
-            </a:r>
-            <a:r>
-              <a:rPr lang="en-US" sz="2400" dirty="0" spc="3" kern="0">
+              <a:t> loại: kiểm</a:t>
+            </a:r>
+            <a:r>
+              <a:rPr lang="en-US" sz="2400" dirty="0" spc="-21" kern="0">
                 <a:solidFill>
                   <a:srgbClr val="E4E1D8"/>
                 </a:solidFill>
@@ -6553,7 +6531,7 @@
                 <a:ea typeface="Be Vietnam Pro" pitchFamily="34" charset="-122"/>
                 <a:cs typeface="Be Vietnam Pro" pitchFamily="34" charset="-120"/>
               </a:rPr>
-              <a:t> tự</a:t>
+              <a:t> tra</a:t>
             </a:r>
             <a:r>
               <a:rPr lang="en-US" sz="2400" dirty="0" spc="2" kern="0">
@@ -6564,10 +6542,10 @@
                 <a:ea typeface="Be Vietnam Pro" pitchFamily="34" charset="-122"/>
                 <a:cs typeface="Be Vietnam Pro" pitchFamily="34" charset="-120"/>
               </a:rPr>
-              <a:t> bị</a:t>
-            </a:r>
-            <a:r>
-              <a:rPr lang="en-US" sz="2400" dirty="0" spc="-1" kern="0">
+              <a:t> phần</a:t>
+            </a:r>
+            <a:r>
+              <a:rPr lang="en-US" sz="2400" dirty="0" spc="-17" kern="0">
                 <a:solidFill>
                   <a:srgbClr val="E4E1D8"/>
                 </a:solidFill>
@@ -6575,10 +6553,10 @@
                 <a:ea typeface="Be Vietnam Pro" pitchFamily="34" charset="-122"/>
                 <a:cs typeface="Be Vietnam Pro" pitchFamily="34" charset="-120"/>
               </a:rPr>
-              <a:t> loại: kiểm</a:t>
-            </a:r>
-            <a:r>
-              <a:rPr lang="en-US" sz="2400" dirty="0" spc="-21" kern="0">
+              <a:t> crawler</a:t>
+            </a:r>
+            <a:r>
+              <a:rPr lang="en-US" sz="2400" dirty="0" spc="-5" kern="0">
                 <a:solidFill>
                   <a:srgbClr val="E4E1D8"/>
                 </a:solidFill>
@@ -6586,73 +6564,7 @@
                 <a:ea typeface="Be Vietnam Pro" pitchFamily="34" charset="-122"/>
                 <a:cs typeface="Be Vietnam Pro" pitchFamily="34" charset="-120"/>
               </a:rPr>
-              <a:t> tra</a:t>
-            </a:r>
-            <a:r>
-              <a:rPr lang="en-US" sz="2400" dirty="0" spc="0" kern="0">
-                <a:solidFill>
-                  <a:srgbClr val="E4E1D8"/>
-                </a:solidFill>
-                <a:latin typeface="Be Vietnam Pro" pitchFamily="34" charset="0"/>
-                <a:ea typeface="Be Vietnam Pro" pitchFamily="34" charset="-122"/>
-                <a:cs typeface="Be Vietnam Pro" pitchFamily="34" charset="-120"/>
-              </a:rPr>
-              <a:t> nội</a:t>
-            </a:r>
-            <a:r>
-              <a:rPr lang="en-US" sz="2400" dirty="0" spc="1" kern="0">
-                <a:solidFill>
-                  <a:srgbClr val="E4E1D8"/>
-                </a:solidFill>
-                <a:latin typeface="Be Vietnam Pro" pitchFamily="34" charset="0"/>
-                <a:ea typeface="Be Vietnam Pro" pitchFamily="34" charset="-122"/>
-                <a:cs typeface="Be Vietnam Pro" pitchFamily="34" charset="-120"/>
-              </a:rPr>
-              <a:t> dung</a:t>
-            </a:r>
-            <a:r>
-              <a:rPr lang="en-US" sz="2400" dirty="0" spc="-17" kern="0">
-                <a:solidFill>
-                  <a:srgbClr val="E4E1D8"/>
-                </a:solidFill>
-                <a:latin typeface="Be Vietnam Pro" pitchFamily="34" charset="0"/>
-                <a:ea typeface="Be Vietnam Pro" pitchFamily="34" charset="-122"/>
-                <a:cs typeface="Be Vietnam Pro" pitchFamily="34" charset="-120"/>
-              </a:rPr>
-              <a:t> crawler</a:t>
-            </a:r>
-            <a:r>
-              <a:rPr lang="en-US" sz="2400" dirty="0" spc="1" kern="0">
-                <a:solidFill>
-                  <a:srgbClr val="E4E1D8"/>
-                </a:solidFill>
-                <a:latin typeface="Be Vietnam Pro" pitchFamily="34" charset="0"/>
-                <a:ea typeface="Be Vietnam Pro" pitchFamily="34" charset="-122"/>
-                <a:cs typeface="Be Vietnam Pro" pitchFamily="34" charset="-120"/>
-              </a:rPr>
-              <a:t> tiếp</a:t>
-            </a:r>
-            <a:r>
-              <a:rPr lang="en-US" sz="2400" dirty="0" spc="0" kern="0">
-                <a:solidFill>
-                  <a:srgbClr val="E4E1D8"/>
-                </a:solidFill>
-                <a:latin typeface="Be Vietnam Pro" pitchFamily="34" charset="0"/>
-                <a:ea typeface="Be Vietnam Pro" pitchFamily="34" charset="-122"/>
-                <a:cs typeface="Be Vietnam Pro" pitchFamily="34" charset="-120"/>
-              </a:rPr>
-              <a:t> cận</a:t>
-            </a:r>
-            <a:r>
-              <a:rPr lang="en-US" sz="2400" dirty="0" spc="5" kern="0">
-                <a:solidFill>
-                  <a:srgbClr val="E4E1D8"/>
-                </a:solidFill>
-                <a:latin typeface="Be Vietnam Pro" pitchFamily="34" charset="0"/>
-                <a:ea typeface="Be Vietnam Pro" pitchFamily="34" charset="-122"/>
-                <a:cs typeface="Be Vietnam Pro" pitchFamily="34" charset="-120"/>
-              </a:rPr>
-              <a:t> được.</a:t>
+              <a:t> thấy.</a:t>
             </a:r>
             <a:endParaRPr lang="en-US" sz="2400" dirty="0"/>
           </a:p>
@@ -8968,7 +8880,7 @@
               <a:t> CỦA</a:t>
             </a:r>
             <a:r>
-              <a:rPr lang="en-US" sz="1800" b="1" spc="297" kern="0" dirty="0">
+              <a:rPr lang="en-US" sz="1800" b="1" spc="295" kern="0" dirty="0">
                 <a:solidFill>
                   <a:srgbClr val="0F766E"/>
                 </a:solidFill>
@@ -8976,84 +8888,7 @@
                 <a:ea typeface="Be Vietnam Pro" pitchFamily="34" charset="-122"/>
                 <a:cs typeface="Be Vietnam Pro" pitchFamily="34" charset="-120"/>
               </a:rPr>
-              <a:t> BẠN:</a:t>
-            </a:r>
-            <a:r>
-              <a:rPr lang="en-US" sz="1800" b="1" spc="300" kern="0" dirty="0">
-                <a:solidFill>
-                  <a:srgbClr val="0F766E"/>
-                </a:solidFill>
-                <a:latin typeface="Be Vietnam Pro" pitchFamily="34" charset="0"/>
-                <a:ea typeface="Be Vietnam Pro" pitchFamily="34" charset="-122"/>
-                <a:cs typeface="Be Vietnam Pro" pitchFamily="34" charset="-120"/>
-              </a:rPr>
-              <a:t> NỘI DUNG</a:t>
-            </a:r>
-            <a:r>
-              <a:rPr lang="en-US" sz="1800" b="1" spc="281" kern="0" dirty="0">
-                <a:solidFill>
-                  <a:srgbClr val="0F766E"/>
-                </a:solidFill>
-                <a:latin typeface="Be Vietnam Pro" pitchFamily="34" charset="0"/>
-                <a:ea typeface="Be Vietnam Pro" pitchFamily="34" charset="-122"/>
-                <a:cs typeface="Be Vietnam Pro" pitchFamily="34" charset="-120"/>
-              </a:rPr>
-              <a:t> RÕ</a:t>
-            </a:r>
-            <a:r>
-              <a:rPr lang="en-US" sz="1800" b="1" spc="300" kern="0" dirty="0">
-                <a:solidFill>
-                  <a:srgbClr val="0F766E"/>
-                </a:solidFill>
-                <a:latin typeface="Be Vietnam Pro" pitchFamily="34" charset="0"/>
-                <a:ea typeface="Be Vietnam Pro" pitchFamily="34" charset="-122"/>
-                <a:cs typeface="Be Vietnam Pro" pitchFamily="34" charset="-120"/>
-              </a:rPr>
-              <a:t> ·</a:t>
-            </a:r>
-            <a:r>
-              <a:rPr lang="en-US" sz="1800" b="1" spc="297" kern="0" dirty="0">
-                <a:solidFill>
-                  <a:srgbClr val="0F766E"/>
-                </a:solidFill>
-                <a:latin typeface="Be Vietnam Pro" pitchFamily="34" charset="0"/>
-                <a:ea typeface="Be Vietnam Pro" pitchFamily="34" charset="-122"/>
-                <a:cs typeface="Be Vietnam Pro" pitchFamily="34" charset="-120"/>
-              </a:rPr>
-              <a:t> TRANG</a:t>
-            </a:r>
-            <a:r>
-              <a:rPr lang="en-US" sz="1800" b="1" spc="296" kern="0" dirty="0">
-                <a:solidFill>
-                  <a:srgbClr val="0F766E"/>
-                </a:solidFill>
-                <a:latin typeface="Be Vietnam Pro" pitchFamily="34" charset="0"/>
-                <a:ea typeface="Be Vietnam Pro" pitchFamily="34" charset="-122"/>
-                <a:cs typeface="Be Vietnam Pro" pitchFamily="34" charset="-120"/>
-              </a:rPr>
-              <a:t> TRUY</a:t>
-            </a:r>
-            <a:r>
-              <a:rPr lang="en-US" sz="1800" b="1" spc="282" kern="0" dirty="0">
-                <a:solidFill>
-                  <a:srgbClr val="0F766E"/>
-                </a:solidFill>
-                <a:latin typeface="Be Vietnam Pro" pitchFamily="34" charset="0"/>
-                <a:ea typeface="Be Vietnam Pro" pitchFamily="34" charset="-122"/>
-                <a:cs typeface="Be Vietnam Pro" pitchFamily="34" charset="-120"/>
-              </a:rPr>
-              <a:t> CẬP</a:t>
-            </a:r>
-            <a:r>
-              <a:rPr lang="en-US" sz="1800" b="1" spc="303" kern="0" dirty="0">
-                <a:solidFill>
-                  <a:srgbClr val="0F766E"/>
-                </a:solidFill>
-                <a:latin typeface="Be Vietnam Pro" pitchFamily="34" charset="0"/>
-                <a:ea typeface="Be Vietnam Pro" pitchFamily="34" charset="-122"/>
-                <a:cs typeface="Be Vietnam Pro" pitchFamily="34" charset="-120"/>
-              </a:rPr>
-              <a:t> ĐƯỢC</a:t>
+              <a:t> BẠN</a:t>
             </a:r>
             <a:endParaRPr lang="en-US" sz="1800" dirty="0"/>
           </a:p>
@@ -13234,6 +13069,50 @@
               <a:t> tốt</a:t>
             </a:r>
             <a:r>
+              <a:rPr lang="en-US" sz="2400" dirty="0" spc="1" kern="0">
+                <a:solidFill>
+                  <a:srgbClr val="14161C"/>
+                </a:solidFill>
+                <a:latin typeface="Be Vietnam Pro" pitchFamily="34" charset="0"/>
+                <a:ea typeface="Be Vietnam Pro" pitchFamily="34" charset="-122"/>
+                <a:cs typeface="Be Vietnam Pro" pitchFamily="34" charset="-120"/>
+              </a:rPr>
+              <a:t> không</a:t>
+            </a:r>
+            <a:r>
+              <a:rPr lang="en-US" sz="2400" dirty="0" spc="0" kern="0">
+                <a:solidFill>
+                  <a:srgbClr val="14161C"/>
+                </a:solidFill>
+                <a:latin typeface="Be Vietnam Pro" pitchFamily="34" charset="0"/>
+                <a:ea typeface="Be Vietnam Pro" pitchFamily="34" charset="-122"/>
+                <a:cs typeface="Be Vietnam Pro" pitchFamily="34" charset="-120"/>
+              </a:rPr>
+              <a:t> bảo</a:t>
+            </a:r>
+            <a:r>
+              <a:rPr lang="en-US" sz="2400" dirty="0" spc="15" kern="0">
+                <a:solidFill>
+                  <a:srgbClr val="14161C"/>
+                </a:solidFill>
+                <a:latin typeface="Be Vietnam Pro" pitchFamily="34" charset="0"/>
+                <a:ea typeface="Be Vietnam Pro" pitchFamily="34" charset="-122"/>
+                <a:cs typeface="Be Vietnam Pro" pitchFamily="34" charset="-120"/>
+              </a:rPr>
+              <a:t> đảm</a:t>
+            </a:r>
+            <a:r>
+              <a:rPr lang="en-US" sz="2400" dirty="0" spc="3" kern="0">
+                <a:solidFill>
+                  <a:srgbClr val="14161C"/>
+                </a:solidFill>
+                <a:latin typeface="Be Vietnam Pro" pitchFamily="34" charset="0"/>
+                <a:ea typeface="Be Vietnam Pro" pitchFamily="34" charset="-122"/>
+                <a:cs typeface="Be Vietnam Pro" pitchFamily="34" charset="-120"/>
+              </a:rPr>
+              <a:t> thứ</a:t>
+            </a:r>
+            <a:r>
               <a:rPr lang="en-US" sz="2400" dirty="0" spc="2" kern="0">
                 <a:solidFill>
                   <a:srgbClr val="14161C"/>
@@ -13242,73 +13121,7 @@
                 <a:ea typeface="Be Vietnam Pro" pitchFamily="34" charset="-122"/>
                 <a:cs typeface="Be Vietnam Pro" pitchFamily="34" charset="-120"/>
               </a:rPr>
-              <a:t> hỗ</a:t>
-            </a:r>
-            <a:r>
-              <a:rPr lang="en-US" sz="2400" dirty="0" spc="-22" kern="0">
-                <a:solidFill>
-                  <a:srgbClr val="14161C"/>
-                </a:solidFill>
-                <a:latin typeface="Be Vietnam Pro" pitchFamily="34" charset="0"/>
-                <a:ea typeface="Be Vietnam Pro" pitchFamily="34" charset="-122"/>
-                <a:cs typeface="Be Vietnam Pro" pitchFamily="34" charset="-120"/>
-              </a:rPr>
-              <a:t> trợ</a:t>
-            </a:r>
-            <a:r>
-              <a:rPr lang="en-US" sz="2400" dirty="0" spc="-17" kern="0">
-                <a:solidFill>
-                  <a:srgbClr val="14161C"/>
-                </a:solidFill>
-                <a:latin typeface="Be Vietnam Pro" pitchFamily="34" charset="0"/>
-                <a:ea typeface="Be Vietnam Pro" pitchFamily="34" charset="-122"/>
-                <a:cs typeface="Be Vietnam Pro" pitchFamily="34" charset="-120"/>
-              </a:rPr>
-              <a:t> trải</a:t>
-            </a:r>
-            <a:r>
-              <a:rPr lang="en-US" sz="2400" dirty="0" spc="1" kern="0">
-                <a:solidFill>
-                  <a:srgbClr val="14161C"/>
-                </a:solidFill>
-                <a:latin typeface="Be Vietnam Pro" pitchFamily="34" charset="0"/>
-                <a:ea typeface="Be Vietnam Pro" pitchFamily="34" charset="-122"/>
-                <a:cs typeface="Be Vietnam Pro" pitchFamily="34" charset="-120"/>
-              </a:rPr>
-              <a:t> nghiệm, không</a:t>
-            </a:r>
-            <a:r>
-              <a:rPr lang="en-US" sz="2400" dirty="0" spc="0" kern="0">
-                <a:solidFill>
-                  <a:srgbClr val="14161C"/>
-                </a:solidFill>
-                <a:latin typeface="Be Vietnam Pro" pitchFamily="34" charset="0"/>
-                <a:ea typeface="Be Vietnam Pro" pitchFamily="34" charset="-122"/>
-                <a:cs typeface="Be Vietnam Pro" pitchFamily="34" charset="-120"/>
-              </a:rPr>
-              <a:t> bảo</a:t>
-            </a:r>
-            <a:r>
-              <a:rPr lang="en-US" sz="2400" dirty="0" spc="15" kern="0">
-                <a:solidFill>
-                  <a:srgbClr val="14161C"/>
-                </a:solidFill>
-                <a:latin typeface="Be Vietnam Pro" pitchFamily="34" charset="0"/>
-                <a:ea typeface="Be Vietnam Pro" pitchFamily="34" charset="-122"/>
-                <a:cs typeface="Be Vietnam Pro" pitchFamily="34" charset="-120"/>
-              </a:rPr>
-              <a:t> đảm</a:t>
-            </a:r>
-            <a:r>
-              <a:rPr lang="en-US" sz="2400" dirty="0" spc="2" kern="0">
-                <a:solidFill>
-                  <a:srgbClr val="14161C"/>
-                </a:solidFill>
-                <a:latin typeface="Be Vietnam Pro" pitchFamily="34" charset="0"/>
-                <a:ea typeface="Be Vietnam Pro" pitchFamily="34" charset="-122"/>
-                <a:cs typeface="Be Vietnam Pro" pitchFamily="34" charset="-120"/>
-              </a:rPr>
-              <a:t> thứ hạng.</a:t>
+              <a:t> hạng.</a:t>
             </a:r>
             <a:endParaRPr lang="en-US" sz="2400" dirty="0"/>
           </a:p>

</xml_diff>

<commit_message>
Slides: re-export sd-09-011 PPTX
Co-Authored-By: Claude Opus 5.5 <noreply@anthropic.com>
Claude-Session: https://claude.ai/code/session_014EdyZwPF7XnU2uvEPKZ7Pf
</commit_message>
<xml_diff>
--- a/system-design-101/vi/lessons/sd-09-011/slides/sd-09-011.pptx
+++ b/system-design-101/vi/lessons/sd-09-011/slides/sd-09-011.pptx
@@ -6512,7 +6512,7 @@
               <a:t> bị</a:t>
             </a:r>
             <a:r>
-              <a:rPr lang="en-US" sz="2400" dirty="0" spc="-1" kern="0">
+              <a:rPr lang="en-US" sz="2400" dirty="0" spc="0" kern="0">
                 <a:solidFill>
                   <a:srgbClr val="E4E1D8"/>
                 </a:solidFill>
@@ -6520,10 +6520,10 @@
                 <a:ea typeface="Be Vietnam Pro" pitchFamily="34" charset="-122"/>
                 <a:cs typeface="Be Vietnam Pro" pitchFamily="34" charset="-120"/>
               </a:rPr>
-              <a:t> loại: kiểm</a:t>
-            </a:r>
-            <a:r>
-              <a:rPr lang="en-US" sz="2400" dirty="0" spc="-21" kern="0">
+              <a:t> loại;</a:t>
+            </a:r>
+            <a:r>
+              <a:rPr lang="en-US" sz="2400" dirty="0" spc="-16" kern="0">
                 <a:solidFill>
                   <a:srgbClr val="E4E1D8"/>
                 </a:solidFill>
@@ -6531,7 +6531,7 @@
                 <a:ea typeface="Be Vietnam Pro" pitchFamily="34" charset="-122"/>
                 <a:cs typeface="Be Vietnam Pro" pitchFamily="34" charset="-120"/>
               </a:rPr>
-              <a:t> tra</a:t>
+              <a:t> xem</a:t>
             </a:r>
             <a:r>
               <a:rPr lang="en-US" sz="2400" dirty="0" spc="2" kern="0">

</xml_diff>